<commit_message>
livrables : le rendu école est un travail de groupe (noms ajoutés : slide de titre, textes, dossiers)
Co-Authored-By: Claude Sonnet 5.5 <noreply@anthropic.com>
</commit_message>
<xml_diff>
--- a/livrables/V1-ecole/3-soutenance/Soutenance_E21_Agents_IA.pptx
+++ b/livrables/V1-ecole/3-soutenance/Soutenance_E21_Agents_IA.pptx
@@ -3251,7 +3251,7 @@
         <p:spPr>
           <a:xfrm>
             <a:off x="548640" y="3931920"/>
-            <a:ext cx="4572000" cy="274320"/>
+            <a:ext cx="4572000" cy="548640"/>
           </a:xfrm>
           <a:prstGeom prst="rect">
             <a:avLst/>
@@ -3275,10 +3275,27 @@
                 <a:ea typeface="Segoe UI Semibold" pitchFamily="34" charset="-122"/>
                 <a:cs typeface="Segoe UI Semibold" pitchFamily="34" charset="-120"/>
               </a:rPr>
-              <a:t>Melvin RAIMBAULT</a:t>
+              <a:t>Melvin RAIMBAULT  ·  Lucas HUARD</a:t>
             </a:r>
             <a:endParaRPr lang="en-US" sz="1300" dirty="0"/>
           </a:p>
+          <a:p>
+            <a:pPr marL="0" indent="0">
+              <a:buNone/>
+            </a:pPr>
+            <a:r>
+              <a:rPr lang="en-US" sz="1300" dirty="0">
+                <a:solidFill>
+                  <a:srgbClr val="FFFFFF"/>
+                </a:solidFill>
+                <a:latin typeface="Segoe UI Semibold" pitchFamily="34" charset="0"/>
+                <a:ea typeface="Segoe UI Semibold" pitchFamily="34" charset="-122"/>
+                <a:cs typeface="Segoe UI Semibold" pitchFamily="34" charset="-120"/>
+              </a:rPr>
+              <a:t>Jérémy LESSA  ·  David AMARO MONTEIRO</a:t>
+            </a:r>
+            <a:endParaRPr lang="en-US" sz="1300" dirty="0"/>
+          </a:p>
         </p:txBody>
       </p:sp>
       <p:sp>
@@ -3289,7 +3306,7 @@
         </p:nvSpPr>
         <p:spPr>
           <a:xfrm>
-            <a:off x="548640" y="4251960"/>
+            <a:off x="548640" y="4553712"/>
             <a:ext cx="4572000" cy="274320"/>
           </a:xfrm>
           <a:prstGeom prst="rect">

</xml_diff>